<commit_message>
reran everything with new 5 hour gps cleaning
</commit_message>
<xml_diff>
--- a/figures/hunting_area_gps/layout.pptx
+++ b/figures/hunting_area_gps/layout.pptx
@@ -259,7 +259,7 @@
           <a:p>
             <a:fld id="{E419B33E-6815-4847-AE9C-F1946337157C}" type="datetimeFigureOut">
               <a:rPr lang="en-US" smtClean="0"/>
-              <a:t>4/21/2026</a:t>
+              <a:t>4/22/2026</a:t>
             </a:fld>
             <a:endParaRPr lang="en-US"/>
           </a:p>
@@ -457,7 +457,7 @@
           <a:p>
             <a:fld id="{E419B33E-6815-4847-AE9C-F1946337157C}" type="datetimeFigureOut">
               <a:rPr lang="en-US" smtClean="0"/>
-              <a:t>4/21/2026</a:t>
+              <a:t>4/22/2026</a:t>
             </a:fld>
             <a:endParaRPr lang="en-US"/>
           </a:p>
@@ -665,7 +665,7 @@
           <a:p>
             <a:fld id="{E419B33E-6815-4847-AE9C-F1946337157C}" type="datetimeFigureOut">
               <a:rPr lang="en-US" smtClean="0"/>
-              <a:t>4/21/2026</a:t>
+              <a:t>4/22/2026</a:t>
             </a:fld>
             <a:endParaRPr lang="en-US"/>
           </a:p>
@@ -863,7 +863,7 @@
           <a:p>
             <a:fld id="{E419B33E-6815-4847-AE9C-F1946337157C}" type="datetimeFigureOut">
               <a:rPr lang="en-US" smtClean="0"/>
-              <a:t>4/21/2026</a:t>
+              <a:t>4/22/2026</a:t>
             </a:fld>
             <a:endParaRPr lang="en-US"/>
           </a:p>
@@ -1138,7 +1138,7 @@
           <a:p>
             <a:fld id="{E419B33E-6815-4847-AE9C-F1946337157C}" type="datetimeFigureOut">
               <a:rPr lang="en-US" smtClean="0"/>
-              <a:t>4/21/2026</a:t>
+              <a:t>4/22/2026</a:t>
             </a:fld>
             <a:endParaRPr lang="en-US"/>
           </a:p>
@@ -1403,7 +1403,7 @@
           <a:p>
             <a:fld id="{E419B33E-6815-4847-AE9C-F1946337157C}" type="datetimeFigureOut">
               <a:rPr lang="en-US" smtClean="0"/>
-              <a:t>4/21/2026</a:t>
+              <a:t>4/22/2026</a:t>
             </a:fld>
             <a:endParaRPr lang="en-US"/>
           </a:p>
@@ -1815,7 +1815,7 @@
           <a:p>
             <a:fld id="{E419B33E-6815-4847-AE9C-F1946337157C}" type="datetimeFigureOut">
               <a:rPr lang="en-US" smtClean="0"/>
-              <a:t>4/21/2026</a:t>
+              <a:t>4/22/2026</a:t>
             </a:fld>
             <a:endParaRPr lang="en-US"/>
           </a:p>
@@ -1956,7 +1956,7 @@
           <a:p>
             <a:fld id="{E419B33E-6815-4847-AE9C-F1946337157C}" type="datetimeFigureOut">
               <a:rPr lang="en-US" smtClean="0"/>
-              <a:t>4/21/2026</a:t>
+              <a:t>4/22/2026</a:t>
             </a:fld>
             <a:endParaRPr lang="en-US"/>
           </a:p>
@@ -2069,7 +2069,7 @@
           <a:p>
             <a:fld id="{E419B33E-6815-4847-AE9C-F1946337157C}" type="datetimeFigureOut">
               <a:rPr lang="en-US" smtClean="0"/>
-              <a:t>4/21/2026</a:t>
+              <a:t>4/22/2026</a:t>
             </a:fld>
             <a:endParaRPr lang="en-US"/>
           </a:p>
@@ -2380,7 +2380,7 @@
           <a:p>
             <a:fld id="{E419B33E-6815-4847-AE9C-F1946337157C}" type="datetimeFigureOut">
               <a:rPr lang="en-US" smtClean="0"/>
-              <a:t>4/21/2026</a:t>
+              <a:t>4/22/2026</a:t>
             </a:fld>
             <a:endParaRPr lang="en-US"/>
           </a:p>
@@ -2668,7 +2668,7 @@
           <a:p>
             <a:fld id="{E419B33E-6815-4847-AE9C-F1946337157C}" type="datetimeFigureOut">
               <a:rPr lang="en-US" smtClean="0"/>
-              <a:t>4/21/2026</a:t>
+              <a:t>4/22/2026</a:t>
             </a:fld>
             <a:endParaRPr lang="en-US"/>
           </a:p>
@@ -2909,7 +2909,7 @@
           <a:p>
             <a:fld id="{E419B33E-6815-4847-AE9C-F1946337157C}" type="datetimeFigureOut">
               <a:rPr lang="en-US" smtClean="0"/>
-              <a:t>4/21/2026</a:t>
+              <a:t>4/22/2026</a:t>
             </a:fld>
             <a:endParaRPr lang="en-US"/>
           </a:p>
@@ -3328,10 +3328,10 @@
       </p:grpSpPr>
       <p:pic>
         <p:nvPicPr>
-          <p:cNvPr id="8" name="Picture 7">
-            <a:extLst>
-              <a:ext uri="{FF2B5EF4-FFF2-40B4-BE49-F238E27FC236}">
-                <a16:creationId xmlns:a16="http://schemas.microsoft.com/office/drawing/2014/main" id="{52E8BA13-EC69-68BB-7761-56829492DAEC}"/>
+          <p:cNvPr id="7" name="Picture 6">
+            <a:extLst>
+              <a:ext uri="{FF2B5EF4-FFF2-40B4-BE49-F238E27FC236}">
+                <a16:creationId xmlns:a16="http://schemas.microsoft.com/office/drawing/2014/main" id="{A4EF1994-8044-DCEE-7FB2-02475AD0370A}"/>
               </a:ext>
             </a:extLst>
           </p:cNvPr>
@@ -3354,43 +3354,7 @@
         </p:blipFill>
         <p:spPr>
           <a:xfrm>
-            <a:off x="6266983" y="3511194"/>
-            <a:ext cx="4462407" cy="3346805"/>
-          </a:xfrm>
-          <a:prstGeom prst="rect">
-            <a:avLst/>
-          </a:prstGeom>
-        </p:spPr>
-      </p:pic>
-      <p:pic>
-        <p:nvPicPr>
-          <p:cNvPr id="12" name="Picture 11">
-            <a:extLst>
-              <a:ext uri="{FF2B5EF4-FFF2-40B4-BE49-F238E27FC236}">
-                <a16:creationId xmlns:a16="http://schemas.microsoft.com/office/drawing/2014/main" id="{337157EC-262B-A02C-6004-6C69DB2D7E32}"/>
-              </a:ext>
-            </a:extLst>
-          </p:cNvPr>
-          <p:cNvPicPr>
-            <a:picLocks noChangeAspect="1"/>
-          </p:cNvPicPr>
-          <p:nvPr/>
-        </p:nvPicPr>
-        <p:blipFill>
-          <a:blip r:embed="rId3">
-            <a:extLst>
-              <a:ext uri="{28A0092B-C50C-407E-A947-70E740481C1C}">
-                <a14:useLocalDpi xmlns:a14="http://schemas.microsoft.com/office/drawing/2010/main" val="0"/>
-              </a:ext>
-            </a:extLst>
-          </a:blip>
-          <a:stretch>
-            <a:fillRect/>
-          </a:stretch>
-        </p:blipFill>
-        <p:spPr>
-          <a:xfrm>
-            <a:off x="6266980" y="-439"/>
+            <a:off x="1621788" y="-439"/>
             <a:ext cx="4462409" cy="3346807"/>
           </a:xfrm>
           <a:prstGeom prst="rect">
@@ -3400,10 +3364,46 @@
       </p:pic>
       <p:pic>
         <p:nvPicPr>
-          <p:cNvPr id="18" name="Picture 17">
-            <a:extLst>
-              <a:ext uri="{FF2B5EF4-FFF2-40B4-BE49-F238E27FC236}">
-                <a16:creationId xmlns:a16="http://schemas.microsoft.com/office/drawing/2014/main" id="{E795CFF6-1F89-E5C6-7ECF-FED87598E3C8}"/>
+          <p:cNvPr id="11" name="Picture 10">
+            <a:extLst>
+              <a:ext uri="{FF2B5EF4-FFF2-40B4-BE49-F238E27FC236}">
+                <a16:creationId xmlns:a16="http://schemas.microsoft.com/office/drawing/2014/main" id="{98563153-6632-D884-49AA-80CB4B073A59}"/>
+              </a:ext>
+            </a:extLst>
+          </p:cNvPr>
+          <p:cNvPicPr>
+            <a:picLocks noChangeAspect="1"/>
+          </p:cNvPicPr>
+          <p:nvPr/>
+        </p:nvPicPr>
+        <p:blipFill>
+          <a:blip r:embed="rId3">
+            <a:extLst>
+              <a:ext uri="{28A0092B-C50C-407E-A947-70E740481C1C}">
+                <a14:useLocalDpi xmlns:a14="http://schemas.microsoft.com/office/drawing/2010/main" val="0"/>
+              </a:ext>
+            </a:extLst>
+          </a:blip>
+          <a:stretch>
+            <a:fillRect/>
+          </a:stretch>
+        </p:blipFill>
+        <p:spPr>
+          <a:xfrm>
+            <a:off x="6266979" y="-9416"/>
+            <a:ext cx="4462409" cy="3346807"/>
+          </a:xfrm>
+          <a:prstGeom prst="rect">
+            <a:avLst/>
+          </a:prstGeom>
+        </p:spPr>
+      </p:pic>
+      <p:pic>
+        <p:nvPicPr>
+          <p:cNvPr id="15" name="Picture 14">
+            <a:extLst>
+              <a:ext uri="{FF2B5EF4-FFF2-40B4-BE49-F238E27FC236}">
+                <a16:creationId xmlns:a16="http://schemas.microsoft.com/office/drawing/2014/main" id="{7B0F07B3-3CC8-E4F3-91CA-E13185B1EAD1}"/>
               </a:ext>
             </a:extLst>
           </p:cNvPr>
@@ -3426,7 +3426,7 @@
         </p:blipFill>
         <p:spPr>
           <a:xfrm>
-            <a:off x="1633592" y="3520046"/>
+            <a:off x="1621788" y="3528898"/>
             <a:ext cx="4450605" cy="3337954"/>
           </a:xfrm>
           <a:prstGeom prst="rect">
@@ -3436,10 +3436,10 @@
       </p:pic>
       <p:pic>
         <p:nvPicPr>
-          <p:cNvPr id="21" name="Picture 20">
-            <a:extLst>
-              <a:ext uri="{FF2B5EF4-FFF2-40B4-BE49-F238E27FC236}">
-                <a16:creationId xmlns:a16="http://schemas.microsoft.com/office/drawing/2014/main" id="{491FE407-94E5-E9CB-42C9-8DBA43104F57}"/>
+          <p:cNvPr id="22" name="Picture 21">
+            <a:extLst>
+              <a:ext uri="{FF2B5EF4-FFF2-40B4-BE49-F238E27FC236}">
+                <a16:creationId xmlns:a16="http://schemas.microsoft.com/office/drawing/2014/main" id="{7B419B76-E120-DBFC-F0CA-83C734FD5CD9}"/>
               </a:ext>
             </a:extLst>
           </p:cNvPr>
@@ -3462,8 +3462,8 @@
         </p:blipFill>
         <p:spPr>
           <a:xfrm>
-            <a:off x="1633590" y="-439"/>
-            <a:ext cx="4450605" cy="3337954"/>
+            <a:off x="6266977" y="3528898"/>
+            <a:ext cx="4462411" cy="3346808"/>
           </a:xfrm>
           <a:prstGeom prst="rect">
             <a:avLst/>
@@ -3500,7 +3500,7 @@
           <a:p>
             <a:r>
               <a:rPr lang="en-US" b="1" dirty="0"/>
-              <a:t>Fall (n = 51)</a:t>
+              <a:t>Fall (n = 358)</a:t>
             </a:r>
           </a:p>
         </p:txBody>
@@ -3535,7 +3535,7 @@
           <a:p>
             <a:r>
               <a:rPr lang="en-US" b="1" dirty="0"/>
-              <a:t>MTFWP hunting (n = 571)</a:t>
+              <a:t>MTFWP hunting (n = 3655)</a:t>
             </a:r>
           </a:p>
         </p:txBody>
@@ -3570,7 +3570,7 @@
           <a:p>
             <a:r>
               <a:rPr lang="en-US" b="1" dirty="0"/>
-              <a:t>Between hunts (n = 994)</a:t>
+              <a:t>Between hunts (n = 4436)</a:t>
             </a:r>
           </a:p>
         </p:txBody>
@@ -3605,7 +3605,7 @@
           <a:p>
             <a:r>
               <a:rPr lang="en-US" b="1" dirty="0"/>
-              <a:t>Bison hunting (n = 2310)</a:t>
+              <a:t>Bison hunting (n = 5523)</a:t>
             </a:r>
           </a:p>
         </p:txBody>

</xml_diff>